<commit_message>
docs(minister): item (iii) — address the proposal to four addressees, add the ZEPARI partnership + endorsement ask and the four-bucket funding route; sync the superseded coverage figures
</commit_message>
<xml_diff>
--- a/Minister Submission/Oreida_Pitch_Deck_Minister_of_ICT.pptx
+++ b/Minister Submission/Oreida_Pitch_Deck_Minister_of_ICT.pptx
@@ -5,7 +5,7 @@
     <p:sldMasterId id="2147483648" r:id="rId1"/>
   </p:sldMasterIdLst>
   <p:notesMasterIdLst>
-    <p:notesMasterId r:id="rId14"/>
+    <p:notesMasterId r:id="rId16"/>
   </p:notesMasterIdLst>
   <p:sldIdLst>
     <p:sldId id="256" r:id="rId2"/>
@@ -20,6 +20,8 @@
     <p:sldId id="265" r:id="rId11"/>
     <p:sldId id="266" r:id="rId12"/>
     <p:sldId id="267" r:id="rId13"/>
+    <p:sldId id="268" r:id="rId14"/>
+    <p:sldId id="269" r:id="rId15"/>
   </p:sldIdLst>
   <p:sldSz cx="9144000" cy="5143500" type="screen16x9"/>
   <p:notesSz cx="6858000" cy="9144000"/>
@@ -617,7 +619,7 @@
             </a:pPr>
             <a:r>
               <a:rPr/>
-              <a:t>These four are the whole ask. Everything else is detail in the proposal document.</a:t>
+              <a:t>Keep the pilot small on purpose. One run is enough to judge the capability.</a:t>
             </a:r>
           </a:p>
         </p:txBody>
@@ -699,7 +701,7 @@
             </a:pPr>
             <a:r>
               <a:rPr/>
-              <a:t>Every figure is an assumption, not an approved cost. A full Treasury business case would follow an approval in principle. Do not quote a total; the figures are placeholders until the Ministry confirms its envelope.</a:t>
+              <a:t>These four are the whole ask. Everything else is detail in the proposal document.</a:t>
             </a:r>
           </a:p>
         </p:txBody>
@@ -781,6 +783,170 @@
             </a:pPr>
             <a:r>
               <a:rPr/>
+              <a:t>Every figure is an assumption, not an approved cost. A full Treasury business case would follow an approval in principle. Do not quote a total; the figures are placeholders until the Ministry confirms its envelope.</a:t>
+            </a:r>
+          </a:p>
+        </p:txBody>
+      </p:sp>
+      <p:sp>
+        <p:nvSpPr>
+          <p:cNvPr id="4" name="Slide Number Placeholder 3"/>
+          <p:cNvSpPr>
+            <a:spLocks noGrp="1"/>
+          </p:cNvSpPr>
+          <p:nvPr>
+            <p:ph type="sldNum" sz="quarter" idx="10"/>
+          </p:nvPr>
+        </p:nvSpPr>
+        <p:spPr/>
+        <p:txBody>
+          <a:bodyPr/>
+          <a:lstStyle/>
+          <a:p>
+            <a:fld id="{18BDFEC3-8487-43E8-A154-7C12CBC1FFF2}" type="slidenum">
+              <a:rPr lang="en-US"/>
+              <a:t>12</a:t>
+            </a:fld>
+            <a:endParaRPr lang="en-US"/>
+          </a:p>
+        </p:txBody>
+      </p:sp>
+    </p:spTree>
+  </p:cSld>
+</p:notes>
+</file>
+
+<file path=ppt/notesSlides/notesSlide13.xml><?xml version="1.0" encoding="utf-8"?>
+<p:notes xmlns:a="http://schemas.openxmlformats.org/drawingml/2006/main" xmlns:r="http://schemas.openxmlformats.org/officeDocument/2006/relationships" xmlns:p="http://schemas.openxmlformats.org/presentationml/2006/main">
+  <p:cSld>
+    <p:spTree>
+      <p:nvGrpSpPr>
+        <p:cNvPr id="1" name=""/>
+        <p:cNvGrpSpPr/>
+        <p:nvPr/>
+      </p:nvGrpSpPr>
+      <p:grpSpPr>
+        <a:xfrm>
+          <a:off x="0" y="0"/>
+          <a:ext cx="0" cy="0"/>
+          <a:chOff x="0" y="0"/>
+          <a:chExt cx="0" cy="0"/>
+        </a:xfrm>
+      </p:grpSpPr>
+      <p:sp>
+        <p:nvSpPr>
+          <p:cNvPr id="2" name="Slide Image Placeholder 1"/>
+          <p:cNvSpPr>
+            <a:spLocks noGrp="1" noRot="1" noChangeAspect="1"/>
+          </p:cNvSpPr>
+          <p:nvPr>
+            <p:ph type="sldImg"/>
+          </p:nvPr>
+        </p:nvSpPr>
+        <p:spPr/>
+      </p:sp>
+      <p:sp>
+        <p:nvSpPr>
+          <p:cNvPr id="3" name="Notes Placeholder 2"/>
+          <p:cNvSpPr>
+            <a:spLocks noGrp="1"/>
+          </p:cNvSpPr>
+          <p:nvPr>
+            <p:ph type="body" idx="1"/>
+          </p:nvPr>
+        </p:nvSpPr>
+        <p:spPr/>
+        <p:txBody>
+          <a:bodyPr/>
+          <a:lstStyle/>
+          <a:p>
+            <a:pPr lvl="0" indent="0" marL="0">
+              <a:buNone/>
+            </a:pPr>
+            <a:r>
+              <a:rPr/>
+              <a:t>No single budget carries the whole cost. Each funding line is a proposed route, not an agreement already in place.</a:t>
+            </a:r>
+          </a:p>
+        </p:txBody>
+      </p:sp>
+      <p:sp>
+        <p:nvSpPr>
+          <p:cNvPr id="4" name="Slide Number Placeholder 3"/>
+          <p:cNvSpPr>
+            <a:spLocks noGrp="1"/>
+          </p:cNvSpPr>
+          <p:nvPr>
+            <p:ph type="sldNum" sz="quarter" idx="10"/>
+          </p:nvPr>
+        </p:nvSpPr>
+        <p:spPr/>
+        <p:txBody>
+          <a:bodyPr/>
+          <a:lstStyle/>
+          <a:p>
+            <a:fld id="{18BDFEC3-8487-43E8-A154-7C12CBC1FFF2}" type="slidenum">
+              <a:rPr lang="en-US"/>
+              <a:t>13</a:t>
+            </a:fld>
+            <a:endParaRPr lang="en-US"/>
+          </a:p>
+        </p:txBody>
+      </p:sp>
+    </p:spTree>
+  </p:cSld>
+</p:notes>
+</file>
+
+<file path=ppt/notesSlides/notesSlide14.xml><?xml version="1.0" encoding="utf-8"?>
+<p:notes xmlns:a="http://schemas.openxmlformats.org/drawingml/2006/main" xmlns:r="http://schemas.openxmlformats.org/officeDocument/2006/relationships" xmlns:p="http://schemas.openxmlformats.org/presentationml/2006/main">
+  <p:cSld>
+    <p:spTree>
+      <p:nvGrpSpPr>
+        <p:cNvPr id="1" name=""/>
+        <p:cNvGrpSpPr/>
+        <p:nvPr/>
+      </p:nvGrpSpPr>
+      <p:grpSpPr>
+        <a:xfrm>
+          <a:off x="0" y="0"/>
+          <a:ext cx="0" cy="0"/>
+          <a:chOff x="0" y="0"/>
+          <a:chExt cx="0" cy="0"/>
+        </a:xfrm>
+      </p:grpSpPr>
+      <p:sp>
+        <p:nvSpPr>
+          <p:cNvPr id="2" name="Slide Image Placeholder 1"/>
+          <p:cNvSpPr>
+            <a:spLocks noGrp="1" noRot="1" noChangeAspect="1"/>
+          </p:cNvSpPr>
+          <p:nvPr>
+            <p:ph type="sldImg"/>
+          </p:nvPr>
+        </p:nvSpPr>
+        <p:spPr/>
+      </p:sp>
+      <p:sp>
+        <p:nvSpPr>
+          <p:cNvPr id="3" name="Notes Placeholder 2"/>
+          <p:cNvSpPr>
+            <a:spLocks noGrp="1"/>
+          </p:cNvSpPr>
+          <p:nvPr>
+            <p:ph type="body" idx="1"/>
+          </p:nvPr>
+        </p:nvSpPr>
+        <p:spPr/>
+        <p:txBody>
+          <a:bodyPr/>
+          <a:lstStyle/>
+          <a:p>
+            <a:pPr lvl="0" indent="0" marL="0">
+              <a:buNone/>
+            </a:pPr>
+            <a:r>
+              <a:rPr/>
               <a:t>Close on the recommendation: approve the pilot, fund the three build steps, host it in the Ministry.</a:t>
             </a:r>
           </a:p>
@@ -803,7 +969,7 @@
           <a:p>
             <a:fld id="{18BDFEC3-8487-43E8-A154-7C12CBC1FFF2}" type="slidenum">
               <a:rPr lang="en-US"/>
-              <a:t>12</a:t>
+              <a:t>14</a:t>
             </a:fld>
             <a:endParaRPr lang="en-US"/>
           </a:p>
@@ -1437,7 +1603,7 @@
             </a:pPr>
             <a:r>
               <a:rPr/>
-              <a:t>Keep the pilot small on purpose. One run is enough to judge the capability.</a:t>
+              <a:t>Say plainly: this is a proposal put to ZEPARI too, not an announcement of their decision.</a:t>
             </a:r>
           </a:p>
         </p:txBody>
@@ -4457,7 +4623,7 @@
             </a:pPr>
             <a:r>
               <a:rPr/>
-              <a:t>Nzwisiso AI™ — A Pilot Policy-Simulation Capability for Digitalize Zimbabwe</a:t>
+              <a:t>Nzwisiso AI™ — A Pilot Policy-Simulation Capability for Digitalize Zimbabwe, in partnership with ZEPARI</a:t>
             </a:r>
           </a:p>
         </p:txBody>
@@ -4491,7 +4657,7 @@
             </a:pPr>
             <a:r>
               <a:rPr/>
-              <a:t>Proposal to the Hon. Tatenda Mavetera, MP — Minister of Information Communication Technology, Postal and Courier Services</a:t>
+              <a:t>Proposal to: the Hon. Tatenda Mavetera, MP — Minister of Information Communication Technology, Postal and Courier Services · Dr. Gibson Chigumira — Executive Director, ZEPARI · Dr. Jesimen Chipika — Deputy Governor, RBZ and Chairperson of the ZEPARI Board of Trustees · the ZEPARI Board of Trustees</a:t>
             </a:r>
           </a:p>
           <a:p>
@@ -4564,7 +4730,7 @@
             </a:pPr>
             <a:r>
               <a:rPr/>
-              <a:t>What approval unlocks</a:t>
+              <a:t>Who it serves first</a:t>
             </a:r>
           </a:p>
         </p:txBody>
@@ -4586,57 +4752,46 @@
           <a:p>
             <a:pPr lvl="0"/>
             <a:r>
+              <a:rPr/>
+              <a:t>The first user is a </a:t>
+            </a:r>
+            <a:r>
               <a:rPr b="1"/>
-              <a:t>Endorsement</a:t>
-            </a:r>
-            <a:r>
-              <a:rPr/>
-              <a:t> of the platform as a pilot for </a:t>
+              <a:t>policy officer</a:t>
+            </a:r>
+            <a:r>
+              <a:rPr/>
+              <a:t> in a department, testing a real draft before it goes up for approval.</a:t>
+            </a:r>
+          </a:p>
+          <a:p>
+            <a:pPr lvl="0"/>
+            <a:r>
+              <a:rPr/>
+              <a:t>The first pilot is </a:t>
             </a:r>
             <a:r>
               <a:rPr b="1"/>
-              <a:t>Digitalize Zimbabwe</a:t>
-            </a:r>
-            <a:r>
-              <a:rPr/>
-              <a:t>.</a:t>
+              <a:t>one institution, one policy question and one run</a:t>
+            </a:r>
+            <a:r>
+              <a:rPr/>
+              <a:t> — small enough to assess honestly.</a:t>
             </a:r>
           </a:p>
           <a:p>
             <a:pPr lvl="0"/>
             <a:r>
+              <a:rPr/>
+              <a:t>The reader of the output is the </a:t>
+            </a:r>
+            <a:r>
               <a:rPr b="1"/>
-              <a:t>Funding</a:t>
-            </a:r>
-            <a:r>
-              <a:rPr/>
-              <a:t> for three named build steps: server-side document text extraction; server-side identity verification; and deployment onto Government infrastructure.</a:t>
-            </a:r>
-          </a:p>
-          <a:p>
-            <a:pPr lvl="0"/>
-            <a:r>
-              <a:rPr b="1"/>
-              <a:t>Hosting</a:t>
-            </a:r>
-            <a:r>
-              <a:rPr/>
-              <a:t> of the pilot inside the Ministry.</a:t>
-            </a:r>
-          </a:p>
-          <a:p>
-            <a:pPr lvl="0"/>
-            <a:r>
-              <a:rPr/>
-              <a:t>A decision on </a:t>
-            </a:r>
-            <a:r>
-              <a:rPr b="1"/>
-              <a:t>one institution and one policy question</a:t>
-            </a:r>
-            <a:r>
-              <a:rPr/>
-              <a:t> to test.</a:t>
+              <a:t>deciding official</a:t>
+            </a:r>
+            <a:r>
+              <a:rPr/>
+              <a:t>: a structured, reproducible assessment they can challenge and act on.</a:t>
             </a:r>
           </a:p>
         </p:txBody>
@@ -4647,6 +4802,144 @@
 </file>
 
 <file path=ppt/slides/slide11.xml><?xml version="1.0" encoding="utf-8"?>
+<p:sld xmlns:a="http://schemas.openxmlformats.org/drawingml/2006/main" xmlns:r="http://schemas.openxmlformats.org/officeDocument/2006/relationships" xmlns:p="http://schemas.openxmlformats.org/presentationml/2006/main">
+  <p:cSld>
+    <p:spTree>
+      <p:nvGrpSpPr>
+        <p:cNvPr id="1" name=""/>
+        <p:cNvGrpSpPr/>
+        <p:nvPr/>
+      </p:nvGrpSpPr>
+      <p:grpSpPr>
+        <a:xfrm>
+          <a:off x="0" y="0"/>
+          <a:ext cx="0" cy="0"/>
+          <a:chOff x="0" y="0"/>
+          <a:chExt cx="0" cy="0"/>
+        </a:xfrm>
+      </p:grpSpPr>
+      <p:sp>
+        <p:nvSpPr>
+          <p:cNvPr id="2" name="Title 1"/>
+          <p:cNvSpPr>
+            <a:spLocks noGrp="1"/>
+          </p:cNvSpPr>
+          <p:nvPr>
+            <p:ph type="title"/>
+          </p:nvPr>
+        </p:nvSpPr>
+        <p:spPr/>
+        <p:txBody>
+          <a:bodyPr/>
+          <a:lstStyle/>
+          <a:p>
+            <a:pPr lvl="0" indent="0" marL="0">
+              <a:buNone/>
+            </a:pPr>
+            <a:r>
+              <a:rPr/>
+              <a:t>What approval unlocks</a:t>
+            </a:r>
+          </a:p>
+        </p:txBody>
+      </p:sp>
+      <p:sp>
+        <p:nvSpPr>
+          <p:cNvPr id="3" name="Content Placeholder 2"/>
+          <p:cNvSpPr>
+            <a:spLocks noGrp="1"/>
+          </p:cNvSpPr>
+          <p:nvPr>
+            <p:ph idx="1"/>
+          </p:nvPr>
+        </p:nvSpPr>
+        <p:spPr/>
+        <p:txBody>
+          <a:bodyPr/>
+          <a:lstStyle/>
+          <a:p>
+            <a:pPr lvl="0"/>
+            <a:r>
+              <a:rPr b="1"/>
+              <a:t>Endorsement</a:t>
+            </a:r>
+            <a:r>
+              <a:rPr/>
+              <a:t> of the platform as a pilot for </a:t>
+            </a:r>
+            <a:r>
+              <a:rPr b="1"/>
+              <a:t>Digitalize Zimbabwe</a:t>
+            </a:r>
+            <a:r>
+              <a:rPr/>
+              <a:t>, and </a:t>
+            </a:r>
+            <a:r>
+              <a:rPr b="1"/>
+              <a:t>ZEPARI’s endorsement</a:t>
+            </a:r>
+            <a:r>
+              <a:rPr/>
+              <a:t> of it as a pilot for ZEPARI’s evidence-based policy work.</a:t>
+            </a:r>
+          </a:p>
+          <a:p>
+            <a:pPr lvl="0"/>
+            <a:r>
+              <a:rPr b="1"/>
+              <a:t>ZEPARI’s partnership</a:t>
+            </a:r>
+            <a:r>
+              <a:rPr/>
+              <a:t> on the evidence base and the methods.</a:t>
+            </a:r>
+          </a:p>
+          <a:p>
+            <a:pPr lvl="0"/>
+            <a:r>
+              <a:rPr b="1"/>
+              <a:t>Funding</a:t>
+            </a:r>
+            <a:r>
+              <a:rPr/>
+              <a:t> for three named build steps: server-side document text extraction; server-side identity verification; and deployment onto Government infrastructure.</a:t>
+            </a:r>
+          </a:p>
+          <a:p>
+            <a:pPr lvl="0"/>
+            <a:r>
+              <a:rPr b="1"/>
+              <a:t>Hosting</a:t>
+            </a:r>
+            <a:r>
+              <a:rPr/>
+              <a:t> of the pilot inside the Ministry.</a:t>
+            </a:r>
+          </a:p>
+          <a:p>
+            <a:pPr lvl="0"/>
+            <a:r>
+              <a:rPr/>
+              <a:t>A decision on </a:t>
+            </a:r>
+            <a:r>
+              <a:rPr b="1"/>
+              <a:t>one institution and one policy question</a:t>
+            </a:r>
+            <a:r>
+              <a:rPr/>
+              <a:t> to test.</a:t>
+            </a:r>
+          </a:p>
+        </p:txBody>
+      </p:sp>
+    </p:spTree>
+  </p:cSld>
+</p:sld>
+</file>
+
+<file path=ppt/slides/slide12.xml><?xml version="1.0" encoding="utf-8"?>
 <p:sld xmlns:a="http://schemas.openxmlformats.org/drawingml/2006/main" xmlns:r="http://schemas.openxmlformats.org/officeDocument/2006/relationships" xmlns:p="http://schemas.openxmlformats.org/presentationml/2006/main">
   <p:cSld>
     <p:spTree>
@@ -5191,7 +5484,7 @@
 </p:sld>
 </file>
 
-<file path=ppt/slides/slide12.xml><?xml version="1.0" encoding="utf-8"?>
+<file path=ppt/slides/slide13.xml><?xml version="1.0" encoding="utf-8"?>
 <p:sld xmlns:a="http://schemas.openxmlformats.org/drawingml/2006/main" xmlns:r="http://schemas.openxmlformats.org/officeDocument/2006/relationships" xmlns:p="http://schemas.openxmlformats.org/presentationml/2006/main">
   <p:cSld>
     <p:spTree>
@@ -5228,6 +5521,179 @@
             </a:pPr>
             <a:r>
               <a:rPr/>
+              <a:t>The proposed funding route</a:t>
+            </a:r>
+          </a:p>
+        </p:txBody>
+      </p:sp>
+      <p:sp>
+        <p:nvSpPr>
+          <p:cNvPr id="3" name="Content Placeholder 2"/>
+          <p:cNvSpPr>
+            <a:spLocks noGrp="1"/>
+          </p:cNvSpPr>
+          <p:nvPr>
+            <p:ph idx="1"/>
+          </p:nvPr>
+        </p:nvSpPr>
+        <p:spPr/>
+        <p:txBody>
+          <a:bodyPr/>
+          <a:lstStyle/>
+          <a:p>
+            <a:pPr lvl="0"/>
+            <a:r>
+              <a:rPr b="1"/>
+              <a:t>The build</a:t>
+            </a:r>
+            <a:r>
+              <a:rPr/>
+              <a:t> — the Ministry of ICT, through </a:t>
+            </a:r>
+            <a:r>
+              <a:rPr b="1"/>
+              <a:t>Treasury</a:t>
+            </a:r>
+            <a:r>
+              <a:rPr/>
+              <a:t>, or the </a:t>
+            </a:r>
+            <a:r>
+              <a:rPr b="1"/>
+              <a:t>POTRAZ Universal Service Fund</a:t>
+            </a:r>
+            <a:r>
+              <a:rPr/>
+              <a:t>.</a:t>
+            </a:r>
+          </a:p>
+          <a:p>
+            <a:pPr lvl="0"/>
+            <a:r>
+              <a:rPr b="1"/>
+              <a:t>Capacity</a:t>
+            </a:r>
+            <a:r>
+              <a:rPr/>
+              <a:t> — </a:t>
+            </a:r>
+            <a:r>
+              <a:rPr b="1"/>
+              <a:t>ZEPARI</a:t>
+            </a:r>
+            <a:r>
+              <a:rPr/>
+              <a:t>, with </a:t>
+            </a:r>
+            <a:r>
+              <a:rPr b="1"/>
+              <a:t>ACBF</a:t>
+            </a:r>
+            <a:r>
+              <a:rPr/>
+              <a:t> (the African Capacity Building Foundation).</a:t>
+            </a:r>
+          </a:p>
+          <a:p>
+            <a:pPr lvl="0"/>
+            <a:r>
+              <a:rPr b="1"/>
+              <a:t>The pilot study</a:t>
+            </a:r>
+            <a:r>
+              <a:rPr/>
+              <a:t> — a </a:t>
+            </a:r>
+            <a:r>
+              <a:rPr b="1"/>
+              <a:t>ZEPARI development partner</a:t>
+            </a:r>
+            <a:r>
+              <a:rPr/>
+              <a:t> (UNDP, AfDB, World Bank or USAID) </a:t>
+            </a:r>
+            <a:r>
+              <a:rPr>
+                <a:latin typeface="Courier"/>
+              </a:rPr>
+              <a:t>[QUESTION — needs a decision]</a:t>
+            </a:r>
+            <a:r>
+              <a:rPr/>
+              <a:t>.</a:t>
+            </a:r>
+          </a:p>
+          <a:p>
+            <a:pPr lvl="0"/>
+            <a:r>
+              <a:rPr b="1"/>
+              <a:t>The first sector pilot</a:t>
+            </a:r>
+            <a:r>
+              <a:rPr/>
+              <a:t> — the </a:t>
+            </a:r>
+            <a:r>
+              <a:rPr b="1"/>
+              <a:t>Chamber of Mines of Zimbabwe</a:t>
+            </a:r>
+            <a:r>
+              <a:rPr/>
+              <a:t> or </a:t>
+            </a:r>
+            <a:r>
+              <a:rPr b="1"/>
+              <a:t>CZI</a:t>
+            </a:r>
+            <a:r>
+              <a:rPr/>
+              <a:t>.</a:t>
+            </a:r>
+          </a:p>
+        </p:txBody>
+      </p:sp>
+    </p:spTree>
+  </p:cSld>
+</p:sld>
+</file>
+
+<file path=ppt/slides/slide14.xml><?xml version="1.0" encoding="utf-8"?>
+<p:sld xmlns:a="http://schemas.openxmlformats.org/drawingml/2006/main" xmlns:r="http://schemas.openxmlformats.org/officeDocument/2006/relationships" xmlns:p="http://schemas.openxmlformats.org/presentationml/2006/main">
+  <p:cSld>
+    <p:spTree>
+      <p:nvGrpSpPr>
+        <p:cNvPr id="1" name=""/>
+        <p:cNvGrpSpPr/>
+        <p:nvPr/>
+      </p:nvGrpSpPr>
+      <p:grpSpPr>
+        <a:xfrm>
+          <a:off x="0" y="0"/>
+          <a:ext cx="0" cy="0"/>
+          <a:chOff x="0" y="0"/>
+          <a:chExt cx="0" cy="0"/>
+        </a:xfrm>
+      </p:grpSpPr>
+      <p:sp>
+        <p:nvSpPr>
+          <p:cNvPr id="2" name="Title 1"/>
+          <p:cNvSpPr>
+            <a:spLocks noGrp="1"/>
+          </p:cNvSpPr>
+          <p:nvPr>
+            <p:ph type="title"/>
+          </p:nvPr>
+        </p:nvSpPr>
+        <p:spPr/>
+        <p:txBody>
+          <a:bodyPr/>
+          <a:lstStyle/>
+          <a:p>
+            <a:pPr lvl="0" indent="0" marL="0">
+              <a:buNone/>
+            </a:pPr>
+            <a:r>
+              <a:rPr/>
               <a:t>The roadmap and the ask</a:t>
             </a:r>
           </a:p>
@@ -5267,6 +5733,22 @@
             </a:r>
             <a:r>
               <a:rPr b="1"/>
+              <a:t>partner with ZEPARI</a:t>
+            </a:r>
+            <a:r>
+              <a:rPr/>
+              <a:t> and </a:t>
+            </a:r>
+            <a:r>
+              <a:rPr b="1"/>
+              <a:t>endorse</a:t>
+            </a:r>
+            <a:r>
+              <a:rPr/>
+              <a:t> it for ZEPARI’s evidence-based policy work; </a:t>
+            </a:r>
+            <a:r>
+              <a:rPr b="1"/>
               <a:t>fund</a:t>
             </a:r>
             <a:r>
@@ -5305,7 +5787,7 @@
             </a:r>
             <a:r>
               <a:rPr/>
-              <a:t> the budget envelope and cost-sharing, the approval deadline, the number of institutions to prioritise first, and the owning office of the programme. </a:t>
+              <a:t> the budget envelope and cost-sharing, the approval deadline, the number of institutions to prioritise first, the owning office of the programme, and ZEPARI’s own approval route for endorsing a pilot. </a:t>
             </a:r>
             <a:r>
               <a:rPr b="1"/>
@@ -5313,7 +5795,7 @@
             </a:r>
             <a:r>
               <a:rPr/>
-              <a:t> the Cabinet Office and the Ministry’s legal desk; the Ministry of ICT; and Treasury.</a:t>
+              <a:t> the Cabinet Office and the Ministry’s legal desk; the Ministry of ICT; ZEPARI; and Treasury.</a:t>
             </a:r>
           </a:p>
           <a:p>
@@ -5501,15 +5983,15 @@
             </a:r>
             <a:r>
               <a:rPr b="1"/>
-              <a:t>72 stakeholder groups</a:t>
-            </a:r>
-            <a:r>
-              <a:rPr/>
-              <a:t> (24 per institution) and holds </a:t>
+              <a:t>150 stakeholder groups</a:t>
+            </a:r>
+            <a:r>
+              <a:rPr/>
+              <a:t> (40 per institution) and holds </a:t>
             </a:r>
             <a:r>
               <a:rPr b="1"/>
-              <a:t>160 reference indicators</a:t>
+              <a:t>510 reference indicators</a:t>
             </a:r>
             <a:r>
               <a:rPr/>
@@ -5632,11 +6114,11 @@
             <a:pPr lvl="0"/>
             <a:r>
               <a:rPr b="1"/>
-              <a:t>72 modelled stakeholder groups</a:t>
-            </a:r>
-            <a:r>
-              <a:rPr/>
-              <a:t> — 20 stand on a published national share, 52 are labelled </a:t>
+              <a:t>150 modelled stakeholder groups</a:t>
+            </a:r>
+            <a:r>
+              <a:rPr/>
+              <a:t> — 20 stand on a published national share, 130 are labelled </a:t>
             </a:r>
             <a:r>
               <a:rPr>
@@ -5653,11 +6135,11 @@
             <a:pPr lvl="0"/>
             <a:r>
               <a:rPr b="1"/>
-              <a:t>160 reference indicators</a:t>
-            </a:r>
-            <a:r>
-              <a:rPr/>
-              <a:t> — 24 are published figures naming their publisher and period, 136 are </a:t>
+              <a:t>510 reference indicators</a:t>
+            </a:r>
+            <a:r>
+              <a:rPr/>
+              <a:t> — 275 are published figures naming their publisher and period, 235 are </a:t>
             </a:r>
             <a:r>
               <a:rPr>
@@ -6270,7 +6752,7 @@
             </a:pPr>
             <a:r>
               <a:rPr/>
-              <a:t>Who it serves first</a:t>
+              <a:t>Why ZEPARI is the research partner</a:t>
             </a:r>
           </a:p>
         </p:txBody>
@@ -6292,46 +6774,61 @@
           <a:p>
             <a:pPr lvl="0"/>
             <a:r>
-              <a:rPr/>
-              <a:t>The first user is a </a:t>
-            </a:r>
-            <a:r>
               <a:rPr b="1"/>
-              <a:t>policy officer</a:t>
-            </a:r>
-            <a:r>
-              <a:rPr/>
-              <a:t> in a department, testing a real draft before it goes up for approval.</a:t>
+              <a:t>ZEPARI</a:t>
+            </a:r>
+            <a:r>
+              <a:rPr/>
+              <a:t> is the </a:t>
+            </a:r>
+            <a:r>
+              <a:rPr b="1"/>
+              <a:t>Zimbabwe Economic Policy Analysis and Research Institute</a:t>
+            </a:r>
+            <a:r>
+              <a:rPr/>
+              <a:t> — an autonomous economic policy analysis and research think-tank, established in 2003 by a Deed of Trust.</a:t>
             </a:r>
           </a:p>
           <a:p>
             <a:pPr lvl="0"/>
             <a:r>
               <a:rPr/>
-              <a:t>The first pilot is </a:t>
+              <a:t>Its stated mission is to conduct applied economic policy analysis, research and capacity building to promote a culture of evidence-based policy making in Zimbabwe.</a:t>
+            </a:r>
+          </a:p>
+          <a:p>
+            <a:pPr lvl="0"/>
+            <a:r>
+              <a:rPr/>
+              <a:t>That is exactly the evidence base this platform consumes. We seek to </a:t>
             </a:r>
             <a:r>
               <a:rPr b="1"/>
-              <a:t>one institution, one policy question and one run</a:t>
-            </a:r>
-            <a:r>
-              <a:rPr/>
-              <a:t> — small enough to assess honestly.</a:t>
+              <a:t>partner with ZEPARI</a:t>
+            </a:r>
+            <a:r>
+              <a:rPr/>
+              <a:t>: the Ministry hosts the capability, and ZEPARI owns the evidence and the methods independently.</a:t>
             </a:r>
           </a:p>
           <a:p>
             <a:pPr lvl="0"/>
             <a:r>
-              <a:rPr/>
-              <a:t>The reader of the output is the </a:t>
-            </a:r>
-            <a:r>
               <a:rPr b="1"/>
-              <a:t>deciding official</a:t>
-            </a:r>
-            <a:r>
-              <a:rPr/>
-              <a:t>: a structured, reproducible assessment they can challenge and act on.</a:t>
+              <a:t>No endorsement is held.</a:t>
+            </a:r>
+            <a:r>
+              <a:rPr/>
+              <a:t> ZEPARI holds </a:t>
+            </a:r>
+            <a:r>
+              <a:rPr b="1"/>
+              <a:t>no</a:t>
+            </a:r>
+            <a:r>
+              <a:rPr/>
+              <a:t> endorsement of this platform today; obtaining ZEPARI’s endorsement is part of the ask.</a:t>
             </a:r>
           </a:p>
         </p:txBody>

</xml_diff>

<commit_message>
deck: rebuilt from its markdown, one untitled slide fixed, and two false claims corrected
The pitch deck was stale since 7 October - it still said the platform makes no network request and that the Ministry hosts it. It is now generated from its own markdown with pandoc -f markdown: 15 slides, every one titled, speaker notes intact, no registered mark, every figure present.

Defect fixed with no word changed: the cost slide had the table before its text, so pandoc silently split it into a second slide with no title. The two bullets now come first.

Two false statements in PROJECT_STATUS.md corrected at source: the deck never contained a registered mark (measured across every part of the file), and pandoc can build its ::: notes (the reader matters, not the tool).

New gates, all proved able to fail: every slide titled; no ::: on a slide; every dollar survived; no registered mark in any document; the committed file matches its markdown.
</commit_message>
<xml_diff>
--- a/Minister Submission/Oreida_Pitch_Deck_Minister_of_ICT.pptx
+++ b/Minister Submission/Oreida_Pitch_Deck_Minister_of_ICT.pptx
@@ -5,7 +5,7 @@
     <p:sldMasterId id="2147483648" r:id="rId1"/>
   </p:sldMasterIdLst>
   <p:notesMasterIdLst>
-    <p:notesMasterId r:id="rId16"/>
+    <p:notesMasterId r:id="rId17"/>
   </p:notesMasterIdLst>
   <p:sldIdLst>
     <p:sldId id="256" r:id="rId2"/>
@@ -22,6 +22,7 @@
     <p:sldId id="267" r:id="rId13"/>
     <p:sldId id="268" r:id="rId14"/>
     <p:sldId id="269" r:id="rId15"/>
+    <p:sldId id="270" r:id="rId16"/>
   </p:sldIdLst>
   <p:sldSz cx="9144000" cy="5143500" type="screen16x9"/>
   <p:notesSz cx="6858000" cy="9144000"/>
@@ -783,7 +784,7 @@
             </a:pPr>
             <a:r>
               <a:rPr/>
-              <a:t>Every figure is an assumption, not an approved cost. A full Treasury business case would follow an approval in principle. Do not quote a total; the figures are placeholders until the Ministry confirms its envelope.</a:t>
+              <a:t>Every figure is the price proposed by Oreida Pvt Ltd, not an approved cost. A full Treasury business case would follow an approval in principle. Everything in the list above is included in either the one-off licence or the monthly service charge — there is no separate charge for hosting, power, connectivity or training.</a:t>
             </a:r>
           </a:p>
         </p:txBody>
@@ -865,7 +866,7 @@
             </a:pPr>
             <a:r>
               <a:rPr/>
-              <a:t>No single budget carries the whole cost. Each funding line is a proposed route, not an agreement already in place.</a:t>
+              <a:t>Lead with Zimbabwe’s own US$20 million appraisal and the US$3 million a year maintenance line: it is our own Government’s own figure, published by the World Bank, and nobody can argue with it. Then the African band. Then the decisive point — our monthly includes hosting, hardware, power and connectivity that theirs excluded. Full citations: World Bank ICR00005623 (4 February 2022); World Bank, Electronic Government Procurement — Implementation Types: Options for Africa, 2022; Government of Zimbabwe National Budget Statement 2019; McKinsey &amp; Company (2012); Journal of Management Information Systems, Vol 39, Issue 3.</a:t>
             </a:r>
           </a:p>
         </p:txBody>
@@ -947,7 +948,7 @@
             </a:pPr>
             <a:r>
               <a:rPr/>
-              <a:t>Close on the recommendation: approve the pilot, fund the three build steps, host it in the Ministry.</a:t>
+              <a:t>No single budget carries the whole cost. Each funding line is a proposed route, not an agreement already in place.</a:t>
             </a:r>
           </a:p>
         </p:txBody>
@@ -970,6 +971,88 @@
             <a:fld id="{18BDFEC3-8487-43E8-A154-7C12CBC1FFF2}" type="slidenum">
               <a:rPr lang="en-US"/>
               <a:t>14</a:t>
+            </a:fld>
+            <a:endParaRPr lang="en-US"/>
+          </a:p>
+        </p:txBody>
+      </p:sp>
+    </p:spTree>
+  </p:cSld>
+</p:notes>
+</file>
+
+<file path=ppt/notesSlides/notesSlide15.xml><?xml version="1.0" encoding="utf-8"?>
+<p:notes xmlns:a="http://schemas.openxmlformats.org/drawingml/2006/main" xmlns:r="http://schemas.openxmlformats.org/officeDocument/2006/relationships" xmlns:p="http://schemas.openxmlformats.org/presentationml/2006/main">
+  <p:cSld>
+    <p:spTree>
+      <p:nvGrpSpPr>
+        <p:cNvPr id="1" name=""/>
+        <p:cNvGrpSpPr/>
+        <p:nvPr/>
+      </p:nvGrpSpPr>
+      <p:grpSpPr>
+        <a:xfrm>
+          <a:off x="0" y="0"/>
+          <a:ext cx="0" cy="0"/>
+          <a:chOff x="0" y="0"/>
+          <a:chExt cx="0" cy="0"/>
+        </a:xfrm>
+      </p:grpSpPr>
+      <p:sp>
+        <p:nvSpPr>
+          <p:cNvPr id="2" name="Slide Image Placeholder 1"/>
+          <p:cNvSpPr>
+            <a:spLocks noGrp="1" noRot="1" noChangeAspect="1"/>
+          </p:cNvSpPr>
+          <p:nvPr>
+            <p:ph type="sldImg"/>
+          </p:nvPr>
+        </p:nvSpPr>
+        <p:spPr/>
+      </p:sp>
+      <p:sp>
+        <p:nvSpPr>
+          <p:cNvPr id="3" name="Notes Placeholder 2"/>
+          <p:cNvSpPr>
+            <a:spLocks noGrp="1"/>
+          </p:cNvSpPr>
+          <p:nvPr>
+            <p:ph type="body" idx="1"/>
+          </p:nvPr>
+        </p:nvSpPr>
+        <p:spPr/>
+        <p:txBody>
+          <a:bodyPr/>
+          <a:lstStyle/>
+          <a:p>
+            <a:pPr lvl="0" indent="0" marL="0">
+              <a:buNone/>
+            </a:pPr>
+            <a:r>
+              <a:rPr/>
+              <a:t>Close on the recommendation: approve the pilot, fund the licence and the three build steps, and approve Oreida Pvt Ltd running and hosting it under the licence.</a:t>
+            </a:r>
+          </a:p>
+        </p:txBody>
+      </p:sp>
+      <p:sp>
+        <p:nvSpPr>
+          <p:cNvPr id="4" name="Slide Number Placeholder 3"/>
+          <p:cNvSpPr>
+            <a:spLocks noGrp="1"/>
+          </p:cNvSpPr>
+          <p:nvPr>
+            <p:ph type="sldNum" sz="quarter" idx="10"/>
+          </p:nvPr>
+        </p:nvSpPr>
+        <p:spPr/>
+        <p:txBody>
+          <a:bodyPr/>
+          <a:lstStyle/>
+          <a:p>
+            <a:fld id="{18BDFEC3-8487-43E8-A154-7C12CBC1FFF2}" type="slidenum">
+              <a:rPr lang="en-US"/>
+              <a:t>15</a:t>
             </a:fld>
             <a:endParaRPr lang="en-US"/>
           </a:p>
@@ -4903,18 +4986,18 @@
             </a:r>
             <a:r>
               <a:rPr/>
-              <a:t> for three named build steps: server-side document text extraction; server-side identity verification; and deployment onto Government infrastructure.</a:t>
+              <a:t> for the licence and three named build steps: server-side document text extraction; server-side identity verification; and deployment to a production service under service levels.</a:t>
             </a:r>
           </a:p>
           <a:p>
             <a:pPr lvl="0"/>
             <a:r>
               <a:rPr b="1"/>
-              <a:t>Hosting</a:t>
-            </a:r>
-            <a:r>
-              <a:rPr/>
-              <a:t> of the pilot inside the Ministry.</a:t>
+              <a:t>Oreida Pvt Ltd running and hosting the platform</a:t>
+            </a:r>
+            <a:r>
+              <a:rPr/>
+              <a:t> for the Ministry, under the public-private partnership and licence.</a:t>
             </a:r>
           </a:p>
           <a:p>
@@ -4966,7 +5049,12 @@
             <p:ph type="title"/>
           </p:nvPr>
         </p:nvSpPr>
-        <p:spPr/>
+        <p:spPr>
+          <a:xfrm>
+            <a:off x="457201" y="204787"/>
+            <a:ext cx="3008313" cy="871538"/>
+          </a:xfrm>
+        </p:spPr>
         <p:txBody>
           <a:bodyPr/>
           <a:lstStyle/>
@@ -4977,6 +5065,80 @@
             <a:r>
               <a:rPr/>
               <a:t>The cost, marked as estimates</a:t>
+            </a:r>
+          </a:p>
+        </p:txBody>
+      </p:sp>
+      <p:sp>
+        <p:nvSpPr>
+          <p:cNvPr id="4" name="Text Placeholder 3"/>
+          <p:cNvSpPr>
+            <a:spLocks noGrp="1"/>
+          </p:cNvSpPr>
+          <p:nvPr>
+            <p:ph idx="2" sz="half" type="body"/>
+          </p:nvPr>
+        </p:nvSpPr>
+        <p:spPr/>
+        <p:txBody>
+          <a:bodyPr/>
+          <a:lstStyle/>
+          <a:p>
+            <a:pPr lvl="0"/>
+            <a:r>
+              <a:rPr b="1"/>
+              <a:t>One price for both tools</a:t>
+            </a:r>
+            <a:r>
+              <a:rPr/>
+              <a:t> — the Nzwisiso AI™ Policy Simulation Assistant and the ZEPARI Research Assistant™. </a:t>
+            </a:r>
+            <a:r>
+              <a:rPr b="1"/>
+              <a:t>No per-tool charge and no per-officer charge.</a:t>
+            </a:r>
+            <a:r>
+              <a:rPr/>
+              <a:t> Either can be used entirely on its own, and they complement each other.</a:t>
+            </a:r>
+          </a:p>
+          <a:p>
+            <a:pPr lvl="0"/>
+            <a:r>
+              <a:rPr/>
+              <a:t>Paid in </a:t>
+            </a:r>
+            <a:r>
+              <a:rPr b="1"/>
+              <a:t>five part-payments as the work is accepted</a:t>
+            </a:r>
+            <a:r>
+              <a:rPr/>
+              <a:t>: a </a:t>
+            </a:r>
+            <a:r>
+              <a:rPr b="1"/>
+              <a:t>1,300,000 licence fee on signature</a:t>
+            </a:r>
+            <a:r>
+              <a:rPr/>
+              <a:t> for software that already exists, a </a:t>
+            </a:r>
+            <a:r>
+              <a:rPr b="1"/>
+              <a:t>500,000 mobilisation advance secured by a bank guarantee</a:t>
+            </a:r>
+            <a:r>
+              <a:rPr/>
+              <a:t>, then </a:t>
+            </a:r>
+            <a:r>
+              <a:rPr b="1"/>
+              <a:t>300,000 + 300,000 + 400,000</a:t>
+            </a:r>
+            <a:r>
+              <a:rPr/>
+              <a:t> on acceptance of the three build steps.</a:t>
             </a:r>
           </a:p>
         </p:txBody>
@@ -4992,8 +5154,8 @@
           </p:nvPr>
         </p:nvGraphicFramePr>
         <p:xfrm>
-          <a:off x="457200" y="1193800"/>
-          <a:ext cx="8229600" cy="3390900"/>
+          <a:off x="3568700" y="203200"/>
+          <a:ext cx="5105400" cy="4381500"/>
         </p:xfrm>
         <a:graphic>
           <a:graphicData uri="http://schemas.openxmlformats.org/drawingml/2006/table">
@@ -5002,11 +5164,10 @@
                 <a:tableStyleId>{5C22544A-7EE6-4342-B048-85BDC9FD1C3A}</a:tableStyleId>
               </a:tblPr>
               <a:tblGrid>
-                <a:gridCol w="1651000"/>
-                <a:gridCol w="1651000"/>
-                <a:gridCol w="1651000"/>
-                <a:gridCol w="1651000"/>
-                <a:gridCol w="1651000"/>
+                <a:gridCol w="1270000"/>
+                <a:gridCol w="1270000"/>
+                <a:gridCol w="1270000"/>
+                <a:gridCol w="1270000"/>
               </a:tblGrid>
               <a:tr h="0">
                 <a:tc>
@@ -5067,23 +5228,7 @@
                       </a:pPr>
                       <a:r>
                         <a:rPr/>
-                        <a:t>Estimate (USD)</a:t>
-                      </a:r>
-                    </a:p>
-                  </a:txBody>
-                  <a:tcPr/>
-                </a:tc>
-                <a:tc>
-                  <a:txBody>
-                    <a:bodyPr/>
-                    <a:lstStyle/>
-                    <a:p>
-                      <a:pPr lvl="0" indent="0" marL="0">
-                        <a:buNone/>
-                      </a:pPr>
-                      <a:r>
-                        <a:rPr/>
-                        <a:t>Estimate (ZWG)</a:t>
+                        <a:t>Price (USD)</a:t>
                       </a:r>
                     </a:p>
                   </a:txBody>
@@ -5146,22 +5291,7 @@
                       </a:pPr>
                       <a:r>
                         <a:rPr/>
-                        <a:t>[ASSUMPTION — to be confirmed]</a:t>
-                      </a:r>
-                    </a:p>
-                  </a:txBody>
-                </a:tc>
-                <a:tc>
-                  <a:txBody>
-                    <a:bodyPr/>
-                    <a:lstStyle/>
-                    <a:p>
-                      <a:pPr lvl="0" indent="0" marL="0">
-                        <a:buNone/>
-                      </a:pPr>
-                      <a:r>
-                        <a:rPr/>
-                        <a:t>[ASSUMPTION — to be confirmed]</a:t>
+                        <a:t>Included in the licence</a:t>
                       </a:r>
                     </a:p>
                   </a:txBody>
@@ -5223,22 +5353,7 @@
                       </a:pPr>
                       <a:r>
                         <a:rPr/>
-                        <a:t>[ASSUMPTION — to be confirmed]</a:t>
-                      </a:r>
-                    </a:p>
-                  </a:txBody>
-                </a:tc>
-                <a:tc>
-                  <a:txBody>
-                    <a:bodyPr/>
-                    <a:lstStyle/>
-                    <a:p>
-                      <a:pPr lvl="0" indent="0" marL="0">
-                        <a:buNone/>
-                      </a:pPr>
-                      <a:r>
-                        <a:rPr/>
-                        <a:t>[ASSUMPTION — to be confirmed]</a:t>
+                        <a:t>Included in the licence</a:t>
                       </a:r>
                     </a:p>
                   </a:txBody>
@@ -5270,7 +5385,7 @@
                       </a:pPr>
                       <a:r>
                         <a:rPr/>
-                        <a:t>Deployment onto Government infrastructure</a:t>
+                        <a:t>Deployment to a production service under service levels</a:t>
                       </a:r>
                     </a:p>
                   </a:txBody>
@@ -5300,22 +5415,7 @@
                       </a:pPr>
                       <a:r>
                         <a:rPr/>
-                        <a:t>[ASSUMPTION — to be confirmed]</a:t>
-                      </a:r>
-                    </a:p>
-                  </a:txBody>
-                </a:tc>
-                <a:tc>
-                  <a:txBody>
-                    <a:bodyPr/>
-                    <a:lstStyle/>
-                    <a:p>
-                      <a:pPr lvl="0" indent="0" marL="0">
-                        <a:buNone/>
-                      </a:pPr>
-                      <a:r>
-                        <a:rPr/>
-                        <a:t>[ASSUMPTION — to be confirmed]</a:t>
+                        <a:t>Included in the licence</a:t>
                       </a:r>
                     </a:p>
                   </a:txBody>
@@ -5377,22 +5477,7 @@
                       </a:pPr>
                       <a:r>
                         <a:rPr/>
-                        <a:t>[ASSUMPTION — to be confirmed]</a:t>
-                      </a:r>
-                    </a:p>
-                  </a:txBody>
-                </a:tc>
-                <a:tc>
-                  <a:txBody>
-                    <a:bodyPr/>
-                    <a:lstStyle/>
-                    <a:p>
-                      <a:pPr lvl="0" indent="0" marL="0">
-                        <a:buNone/>
-                      </a:pPr>
-                      <a:r>
-                        <a:rPr/>
-                        <a:t>[ASSUMPTION — to be confirmed]</a:t>
+                        <a:t>Included in the licence</a:t>
                       </a:r>
                     </a:p>
                   </a:txBody>
@@ -5454,7 +5539,37 @@
                       </a:pPr>
                       <a:r>
                         <a:rPr/>
-                        <a:t>[ASSUMPTION — to be confirmed]</a:t>
+                        <a:t>Included in the monthly service charge</a:t>
+                      </a:r>
+                    </a:p>
+                  </a:txBody>
+                </a:tc>
+              </a:tr>
+              <a:tr h="0">
+                <a:tc>
+                  <a:txBody>
+                    <a:bodyPr/>
+                    <a:lstStyle/>
+                    <a:p>
+                      <a:endParaRPr/>
+                    </a:p>
+                  </a:txBody>
+                </a:tc>
+                <a:tc>
+                  <a:txBody>
+                    <a:bodyPr/>
+                    <a:lstStyle/>
+                    <a:p>
+                      <a:pPr lvl="0" indent="0" marL="0">
+                        <a:buNone/>
+                      </a:pPr>
+                      <a:r>
+                        <a:rPr b="1"/>
+                        <a:t>One-off licence</a:t>
+                      </a:r>
+                      <a:r>
+                        <a:rPr/>
+                        <a:t> — design, build, deployment and training</a:t>
                       </a:r>
                     </a:p>
                   </a:txBody>
@@ -5469,7 +5584,82 @@
                       </a:pPr>
                       <a:r>
                         <a:rPr/>
-                        <a:t>[ASSUMPTION — to be confirmed]</a:t>
+                        <a:t>One-off</a:t>
+                      </a:r>
+                    </a:p>
+                  </a:txBody>
+                </a:tc>
+                <a:tc>
+                  <a:txBody>
+                    <a:bodyPr/>
+                    <a:lstStyle/>
+                    <a:p>
+                      <a:pPr lvl="0" indent="0" marL="0">
+                        <a:buNone/>
+                      </a:pPr>
+                      <a:r>
+                        <a:rPr b="1"/>
+                        <a:t>2,800,000</a:t>
+                      </a:r>
+                    </a:p>
+                  </a:txBody>
+                </a:tc>
+              </a:tr>
+              <a:tr h="0">
+                <a:tc>
+                  <a:txBody>
+                    <a:bodyPr/>
+                    <a:lstStyle/>
+                    <a:p>
+                      <a:endParaRPr/>
+                    </a:p>
+                  </a:txBody>
+                </a:tc>
+                <a:tc>
+                  <a:txBody>
+                    <a:bodyPr/>
+                    <a:lstStyle/>
+                    <a:p>
+                      <a:pPr lvl="0" indent="0" marL="0">
+                        <a:buNone/>
+                      </a:pPr>
+                      <a:r>
+                        <a:rPr b="1"/>
+                        <a:t>Monthly service charge</a:t>
+                      </a:r>
+                      <a:r>
+                        <a:rPr/>
+                        <a:t> — hosting, running, power, connectivity, support and updates</a:t>
+                      </a:r>
+                    </a:p>
+                  </a:txBody>
+                </a:tc>
+                <a:tc>
+                  <a:txBody>
+                    <a:bodyPr/>
+                    <a:lstStyle/>
+                    <a:p>
+                      <a:pPr lvl="0" indent="0" marL="0">
+                        <a:buNone/>
+                      </a:pPr>
+                      <a:r>
+                        <a:rPr/>
+                        <a:t>Recurring</a:t>
+                      </a:r>
+                    </a:p>
+                  </a:txBody>
+                </a:tc>
+                <a:tc>
+                  <a:txBody>
+                    <a:bodyPr/>
+                    <a:lstStyle/>
+                    <a:p>
+                      <a:pPr lvl="0" indent="0" marL="0">
+                        <a:buNone/>
+                      </a:pPr>
+                      <a:r>
+                        <a:rPr b="1"/>
+                        <a:t>72,000 per month</a:t>
                       </a:r>
                     </a:p>
                   </a:txBody>
@@ -5521,7 +5711,7 @@
             </a:pPr>
             <a:r>
               <a:rPr/>
-              <a:t>The proposed funding route</a:t>
+              <a:t>How this compares</a:t>
             </a:r>
           </a:p>
         </p:txBody>
@@ -5543,24 +5733,36 @@
           <a:p>
             <a:pPr lvl="0"/>
             <a:r>
-              <a:rPr b="1"/>
-              <a:t>The build</a:t>
-            </a:r>
-            <a:r>
-              <a:rPr/>
-              <a:t> — the Ministry of ICT, through </a:t>
-            </a:r>
-            <a:r>
-              <a:rPr b="1"/>
-              <a:t>Treasury</a:t>
-            </a:r>
-            <a:r>
-              <a:rPr/>
-              <a:t>, or the </a:t>
-            </a:r>
-            <a:r>
-              <a:rPr b="1"/>
-              <a:t>POTRAZ Universal Service Fund</a:t>
+              <a:rPr/>
+              <a:t>Zimbabwe’s Ministry of Finance had a financial-management system project appraised at </a:t>
+            </a:r>
+            <a:r>
+              <a:rPr b="1"/>
+              <a:t>US$20 million</a:t>
+            </a:r>
+            <a:r>
+              <a:rPr/>
+              <a:t> and signed at </a:t>
+            </a:r>
+            <a:r>
+              <a:rPr b="1"/>
+              <a:t>US$10 million</a:t>
+            </a:r>
+            <a:r>
+              <a:rPr/>
+              <a:t> — and the Government pays </a:t>
+            </a:r>
+            <a:r>
+              <a:rPr b="1"/>
+              <a:t>approximately US$3 million a year</a:t>
+            </a:r>
+            <a:r>
+              <a:rPr/>
+              <a:t> just to maintain that system </a:t>
+            </a:r>
+            <a:r>
+              <a:rPr i="1"/>
+              <a:t>(World Bank, Zimbabwe: Public Financial Management Enhancement Project, ICR00005623, 4 February 2022)</a:t>
             </a:r>
             <a:r>
               <a:rPr/>
@@ -5570,53 +5772,71 @@
           <a:p>
             <a:pPr lvl="0"/>
             <a:r>
-              <a:rPr b="1"/>
-              <a:t>Capacity</a:t>
-            </a:r>
-            <a:r>
-              <a:rPr/>
-              <a:t> — </a:t>
-            </a:r>
-            <a:r>
-              <a:rPr b="1"/>
-              <a:t>ZEPARI</a:t>
-            </a:r>
-            <a:r>
-              <a:rPr/>
-              <a:t>, with </a:t>
-            </a:r>
-            <a:r>
-              <a:rPr b="1"/>
-              <a:t>ACBF</a:t>
-            </a:r>
-            <a:r>
-              <a:rPr/>
-              <a:t> (the African Capacity Building Foundation).</a:t>
+              <a:rPr/>
+              <a:t>Comparable national platforms built by other African governments cost </a:t>
+            </a:r>
+            <a:r>
+              <a:rPr b="1"/>
+              <a:t>US$1.45 million to US$7.8 million</a:t>
+            </a:r>
+            <a:r>
+              <a:rPr/>
+              <a:t> to design and build, with annual running of </a:t>
+            </a:r>
+            <a:r>
+              <a:rPr b="1"/>
+              <a:t>US$155,000 to US$873,000</a:t>
+            </a:r>
+            <a:r>
+              <a:rPr/>
+              <a:t> </a:t>
+            </a:r>
+            <a:r>
+              <a:rPr i="1"/>
+              <a:t>(World Bank, Electronic Government Procurement — Implementation Types: Options for Africa, 2022, pages 99–110)</a:t>
+            </a:r>
+            <a:r>
+              <a:rPr/>
+              <a:t>.</a:t>
             </a:r>
           </a:p>
           <a:p>
             <a:pPr lvl="0"/>
             <a:r>
               <a:rPr b="1"/>
-              <a:t>The pilot study</a:t>
-            </a:r>
-            <a:r>
-              <a:rPr/>
-              <a:t> — a </a:t>
-            </a:r>
-            <a:r>
-              <a:rPr b="1"/>
-              <a:t>ZEPARI development partner</a:t>
-            </a:r>
-            <a:r>
-              <a:rPr/>
-              <a:t> (UNDP, AfDB, World Bank or USAID) </a:t>
-            </a:r>
-            <a:r>
-              <a:rPr>
-                <a:latin typeface="Courier"/>
-              </a:rPr>
-              <a:t>[QUESTION — needs a decision]</a:t>
+              <a:t>Zimbabwe’s own budget</a:t>
+            </a:r>
+            <a:r>
+              <a:rPr/>
+              <a:t> allocated </a:t>
+            </a:r>
+            <a:r>
+              <a:rPr b="1"/>
+              <a:t>US$1.7 million</a:t>
+            </a:r>
+            <a:r>
+              <a:rPr/>
+              <a:t> to establishing </a:t>
+            </a:r>
+            <a:r>
+              <a:rPr b="1"/>
+              <a:t>one</a:t>
+            </a:r>
+            <a:r>
+              <a:rPr/>
+              <a:t> information system — the automated mining cadastre — in 2018, and it was </a:t>
+            </a:r>
+            <a:r>
+              <a:rPr b="1"/>
+              <a:t>never spent</a:t>
+            </a:r>
+            <a:r>
+              <a:rPr/>
+              <a:t> </a:t>
+            </a:r>
+            <a:r>
+              <a:rPr i="1"/>
+              <a:t>(Government of Zimbabwe National Budget Statement 2019)</a:t>
             </a:r>
             <a:r>
               <a:rPr/>
@@ -5626,24 +5846,67 @@
           <a:p>
             <a:pPr lvl="0"/>
             <a:r>
-              <a:rPr b="1"/>
-              <a:t>The first sector pilot</a:t>
-            </a:r>
-            <a:r>
-              <a:rPr/>
-              <a:t> — the </a:t>
-            </a:r>
-            <a:r>
-              <a:rPr b="1"/>
-              <a:t>Chamber of Mines of Zimbabwe</a:t>
-            </a:r>
-            <a:r>
-              <a:rPr/>
-              <a:t> or </a:t>
-            </a:r>
-            <a:r>
-              <a:rPr b="1"/>
-              <a:t>CZI</a:t>
+              <a:rPr/>
+              <a:t>Our price sits </a:t>
+            </a:r>
+            <a:r>
+              <a:rPr b="1"/>
+              <a:t>inside both published ranges</a:t>
+            </a:r>
+            <a:r>
+              <a:rPr/>
+              <a:t>: a one-off of </a:t>
+            </a:r>
+            <a:r>
+              <a:rPr b="1"/>
+              <a:t>US$2,800,000</a:t>
+            </a:r>
+            <a:r>
+              <a:rPr/>
+              <a:t>, and </a:t>
+            </a:r>
+            <a:r>
+              <a:rPr b="1"/>
+              <a:t>US$72,000 a month</a:t>
+            </a:r>
+            <a:r>
+              <a:rPr/>
+              <a:t> that includes hosting, hardware, power, connectivity, support and updates — where the comparators’ annual figures </a:t>
+            </a:r>
+            <a:r>
+              <a:rPr b="1"/>
+              <a:t>excluded</a:t>
+            </a:r>
+            <a:r>
+              <a:rPr/>
+              <a:t> hosting.</a:t>
+            </a:r>
+          </a:p>
+          <a:p>
+            <a:pPr lvl="0"/>
+            <a:r>
+              <a:rPr/>
+              <a:t>The published record on building it yourself: large IT projects run </a:t>
+            </a:r>
+            <a:r>
+              <a:rPr b="1"/>
+              <a:t>45% over budget on average</a:t>
+            </a:r>
+            <a:r>
+              <a:rPr/>
+              <a:t>, and </a:t>
+            </a:r>
+            <a:r>
+              <a:rPr b="1"/>
+              <a:t>18% of IT projects overrun by more than 50%</a:t>
+            </a:r>
+            <a:r>
+              <a:rPr/>
+              <a:t> — those by </a:t>
+            </a:r>
+            <a:r>
+              <a:rPr b="1"/>
+              <a:t>447%</a:t>
             </a:r>
             <a:r>
               <a:rPr/>
@@ -5694,6 +5957,179 @@
             </a:pPr>
             <a:r>
               <a:rPr/>
+              <a:t>The proposed funding route</a:t>
+            </a:r>
+          </a:p>
+        </p:txBody>
+      </p:sp>
+      <p:sp>
+        <p:nvSpPr>
+          <p:cNvPr id="3" name="Content Placeholder 2"/>
+          <p:cNvSpPr>
+            <a:spLocks noGrp="1"/>
+          </p:cNvSpPr>
+          <p:nvPr>
+            <p:ph idx="1"/>
+          </p:nvPr>
+        </p:nvSpPr>
+        <p:spPr/>
+        <p:txBody>
+          <a:bodyPr/>
+          <a:lstStyle/>
+          <a:p>
+            <a:pPr lvl="0"/>
+            <a:r>
+              <a:rPr b="1"/>
+              <a:t>The licence and the build</a:t>
+            </a:r>
+            <a:r>
+              <a:rPr/>
+              <a:t> — the Ministry of ICT, through </a:t>
+            </a:r>
+            <a:r>
+              <a:rPr b="1"/>
+              <a:t>Treasury</a:t>
+            </a:r>
+            <a:r>
+              <a:rPr/>
+              <a:t>, or the </a:t>
+            </a:r>
+            <a:r>
+              <a:rPr b="1"/>
+              <a:t>POTRAZ Universal Service Fund</a:t>
+            </a:r>
+            <a:r>
+              <a:rPr/>
+              <a:t>.</a:t>
+            </a:r>
+          </a:p>
+          <a:p>
+            <a:pPr lvl="0"/>
+            <a:r>
+              <a:rPr b="1"/>
+              <a:t>Capacity</a:t>
+            </a:r>
+            <a:r>
+              <a:rPr/>
+              <a:t> — </a:t>
+            </a:r>
+            <a:r>
+              <a:rPr b="1"/>
+              <a:t>ZEPARI</a:t>
+            </a:r>
+            <a:r>
+              <a:rPr/>
+              <a:t>, with </a:t>
+            </a:r>
+            <a:r>
+              <a:rPr b="1"/>
+              <a:t>ACBF</a:t>
+            </a:r>
+            <a:r>
+              <a:rPr/>
+              <a:t> (the African Capacity Building Foundation).</a:t>
+            </a:r>
+          </a:p>
+          <a:p>
+            <a:pPr lvl="0"/>
+            <a:r>
+              <a:rPr b="1"/>
+              <a:t>The pilot study</a:t>
+            </a:r>
+            <a:r>
+              <a:rPr/>
+              <a:t> — a </a:t>
+            </a:r>
+            <a:r>
+              <a:rPr b="1"/>
+              <a:t>ZEPARI development partner</a:t>
+            </a:r>
+            <a:r>
+              <a:rPr/>
+              <a:t> (UNDP, AfDB, World Bank or USAID) </a:t>
+            </a:r>
+            <a:r>
+              <a:rPr>
+                <a:latin typeface="Courier"/>
+              </a:rPr>
+              <a:t>[QUESTION — needs a decision]</a:t>
+            </a:r>
+            <a:r>
+              <a:rPr/>
+              <a:t>.</a:t>
+            </a:r>
+          </a:p>
+          <a:p>
+            <a:pPr lvl="0"/>
+            <a:r>
+              <a:rPr b="1"/>
+              <a:t>The first sector pilot</a:t>
+            </a:r>
+            <a:r>
+              <a:rPr/>
+              <a:t> — the </a:t>
+            </a:r>
+            <a:r>
+              <a:rPr b="1"/>
+              <a:t>Chamber of Mines of Zimbabwe</a:t>
+            </a:r>
+            <a:r>
+              <a:rPr/>
+              <a:t> or </a:t>
+            </a:r>
+            <a:r>
+              <a:rPr b="1"/>
+              <a:t>CZI</a:t>
+            </a:r>
+            <a:r>
+              <a:rPr/>
+              <a:t>.</a:t>
+            </a:r>
+          </a:p>
+        </p:txBody>
+      </p:sp>
+    </p:spTree>
+  </p:cSld>
+</p:sld>
+</file>
+
+<file path=ppt/slides/slide15.xml><?xml version="1.0" encoding="utf-8"?>
+<p:sld xmlns:a="http://schemas.openxmlformats.org/drawingml/2006/main" xmlns:r="http://schemas.openxmlformats.org/officeDocument/2006/relationships" xmlns:p="http://schemas.openxmlformats.org/presentationml/2006/main">
+  <p:cSld>
+    <p:spTree>
+      <p:nvGrpSpPr>
+        <p:cNvPr id="1" name=""/>
+        <p:cNvGrpSpPr/>
+        <p:nvPr/>
+      </p:nvGrpSpPr>
+      <p:grpSpPr>
+        <a:xfrm>
+          <a:off x="0" y="0"/>
+          <a:ext cx="0" cy="0"/>
+          <a:chOff x="0" y="0"/>
+          <a:chExt cx="0" cy="0"/>
+        </a:xfrm>
+      </p:grpSpPr>
+      <p:sp>
+        <p:nvSpPr>
+          <p:cNvPr id="2" name="Title 1"/>
+          <p:cNvSpPr>
+            <a:spLocks noGrp="1"/>
+          </p:cNvSpPr>
+          <p:nvPr>
+            <p:ph type="title"/>
+          </p:nvPr>
+        </p:nvSpPr>
+        <p:spPr/>
+        <p:txBody>
+          <a:bodyPr/>
+          <a:lstStyle/>
+          <a:p>
+            <a:pPr lvl="0" indent="0" marL="0">
+              <a:buNone/>
+            </a:pPr>
+            <a:r>
+              <a:rPr/>
               <a:t>The roadmap and the ask</a:t>
             </a:r>
           </a:p>
@@ -5753,15 +6189,15 @@
             </a:r>
             <a:r>
               <a:rPr/>
-              <a:t> the three build steps; </a:t>
-            </a:r>
-            <a:r>
-              <a:rPr b="1"/>
-              <a:t>host</a:t>
-            </a:r>
-            <a:r>
-              <a:rPr/>
-              <a:t> it in the Ministry; </a:t>
+              <a:t> the licence and the three build steps; </a:t>
+            </a:r>
+            <a:r>
+              <a:rPr b="1"/>
+              <a:t>approve Oreida Pvt Ltd running and hosting it</a:t>
+            </a:r>
+            <a:r>
+              <a:rPr/>
+              <a:t> under the licence; </a:t>
             </a:r>
             <a:r>
               <a:rPr b="1"/>
@@ -6025,15 +6461,31 @@
             <a:pPr lvl="0"/>
             <a:r>
               <a:rPr/>
-              <a:t>It makes </a:t>
-            </a:r>
-            <a:r>
-              <a:rPr b="1"/>
-              <a:t>no network request at all</a:t>
-            </a:r>
-            <a:r>
-              <a:rPr/>
-              <a:t>: no external AI service, no third-party script, and no document text leaves the machine.</a:t>
+              <a:t>The simulation runs </a:t>
+            </a:r>
+            <a:r>
+              <a:rPr b="1"/>
+              <a:t>entirely on the reader’s own machine</a:t>
+            </a:r>
+            <a:r>
+              <a:rPr/>
+              <a:t> — no third-party script and no outside font is ever fetched. The parts written by the AI come from the </a:t>
+            </a:r>
+            <a:r>
+              <a:rPr b="1"/>
+              <a:t>Nzwisiso AI Policy Simulation Engine™</a:t>
+            </a:r>
+            <a:r>
+              <a:rPr/>
+              <a:t>, which the platform calls over an interface and which runs on </a:t>
+            </a:r>
+            <a:r>
+              <a:rPr b="1"/>
+              <a:t>Oreida Pvt Ltd’s own servers</a:t>
+            </a:r>
+            <a:r>
+              <a:rPr/>
+              <a:t> under the licence.</a:t>
             </a:r>
           </a:p>
         </p:txBody>
@@ -6271,7 +6723,19 @@
             </a:r>
             <a:r>
               <a:rPr/>
-              <a:t> the demonstration does not need it. The platform makes no network request, so it runs from the local build exactly as it does online.</a:t>
+              <a:t> the simulation still runs in full, because it is computed on the reader’s own machine. Only the AI-written parts (the drafted policy, the research answers) need the engine to be reachable — so </a:t>
+            </a:r>
+            <a:r>
+              <a:rPr b="1"/>
+              <a:t>do the live demonstration with connectivity</a:t>
+            </a:r>
+            <a:r>
+              <a:rPr/>
+              <a:t>. </a:t>
+            </a:r>
+            <a:r>
+              <a:rPr i="1"/>
+              <a:t>(Corrected 2026-10-11: this bullet previously said the platform “makes no network request”, which stopped being true once the AI keys were built in.)</a:t>
             </a:r>
           </a:p>
         </p:txBody>
@@ -6682,7 +7146,7 @@
             </a:r>
             <a:r>
               <a:rPr b="1"/>
-              <a:t>working, sovereign example that the Ministry itself hosts</a:t>
+              <a:t>working, sovereign example that the Ministry itself can put to work</a:t>
             </a:r>
             <a:r>
               <a:rPr/>
@@ -6809,7 +7273,7 @@
             </a:r>
             <a:r>
               <a:rPr/>
-              <a:t>: the Ministry hosts the capability, and ZEPARI owns the evidence and the methods independently.</a:t>
+              <a:t>: the Ministry puts the capability to work, and ZEPARI owns the evidence and the methods independently.</a:t>
             </a:r>
           </a:p>
           <a:p>

</xml_diff>